<commit_message>
docs: slide kỹ thuật 2 chỉ mô tả cách hẹn giờ bằng deadline
</commit_message>
<xml_diff>
--- a/docs/Bai-4-Ran-san-moi-Ly-thuyet-va-ky-thuat.pptx
+++ b/docs/Bai-4-Ran-san-moi-Ly-thuyet-va-ky-thuat.pptx
@@ -6587,7 +6587,7 @@
                 <a:ea typeface="Georgia" pitchFamily="34" charset="-122"/>
                 <a:cs typeface="Georgia" pitchFamily="34" charset="-120"/>
               </a:rPr>
-              <a:t>Kỹ thuật 2 — Deadline thay vì đếm frame</a:t>
+              <a:t>Kỹ thuật 2 — Hẹn giờ bằng deadline</a:t>
             </a:r>
             <a:endParaRPr lang="en-US" sz="2900" dirty="0"/>
           </a:p>
@@ -6673,323 +6673,235 @@
       </p:sp>
       <p:sp>
         <p:nvSpPr>
-          <p:cNvPr id="7" name="Shape 5"/>
-          <p:cNvSpPr/>
-          <p:nvPr/>
-        </p:nvSpPr>
-        <p:spPr>
-          <a:xfrm>
-            <a:off x="548640" y="1828800"/>
-            <a:ext cx="5440680" cy="2651760"/>
-          </a:xfrm>
-          <a:prstGeom prst="rect">
-            <a:avLst/>
-          </a:prstGeom>
-          <a:solidFill>
-            <a:srgbClr val="2A1B1D"/>
-          </a:solidFill>
-          <a:ln w="12700">
-            <a:solidFill>
-              <a:srgbClr val="7A3B3F"/>
-            </a:solidFill>
-            <a:prstDash val="solid"/>
-          </a:ln>
-        </p:spPr>
-      </p:sp>
-      <p:sp>
-        <p:nvSpPr>
-          <p:cNvPr id="8" name="Text 6"/>
-          <p:cNvSpPr/>
-          <p:nvPr/>
-        </p:nvSpPr>
-        <p:spPr>
-          <a:xfrm>
-            <a:off x="777240" y="1938528"/>
-            <a:ext cx="4114800" cy="365760"/>
-          </a:xfrm>
-          <a:prstGeom prst="rect">
-            <a:avLst/>
-          </a:prstGeom>
-          <a:noFill/>
-          <a:ln/>
-        </p:spPr>
-        <p:txBody>
-          <a:bodyPr wrap="square" lIns="0" tIns="0" rIns="0" bIns="0" rtlCol="0" anchor="ctr"/>
-          <a:lstStyle/>
-          <a:p>
-            <a:pPr indent="0" marL="0">
-              <a:buNone/>
-            </a:pPr>
-            <a:r>
-              <a:rPr lang="en-US" sz="1500" b="1" dirty="0">
-                <a:solidFill>
-                  <a:srgbClr val="F05A5A"/>
+          <p:cNvPr id="7" name="Text 5"/>
+          <p:cNvSpPr/>
+          <p:nvPr/>
+        </p:nvSpPr>
+        <p:spPr>
+          <a:xfrm>
+            <a:off x="548640" y="1874520"/>
+            <a:ext cx="5212080" cy="2926080"/>
+          </a:xfrm>
+          <a:prstGeom prst="rect">
+            <a:avLst/>
+          </a:prstGeom>
+          <a:noFill/>
+          <a:ln/>
+        </p:spPr>
+        <p:txBody>
+          <a:bodyPr wrap="square" lIns="0" tIns="0" rIns="0" bIns="0" rtlCol="0" anchor="t"/>
+          <a:lstStyle/>
+          <a:p>
+            <a:pPr marL="342900" indent="-342900">
+              <a:spcAft>
+                <a:spcPts val="1200"/>
+              </a:spcAft>
+              <a:buSzPct val="100000"/>
+              <a:buChar char="•"/>
+            </a:pPr>
+            <a:r>
+              <a:rPr lang="en-US" sz="1450" dirty="0">
+                <a:solidFill>
+                  <a:srgbClr val="E9ECF4"/>
                 </a:solidFill>
                 <a:latin typeface="Calibri" pitchFamily="34" charset="0"/>
                 <a:ea typeface="Calibri" pitchFamily="34" charset="-122"/>
                 <a:cs typeface="Calibri" pitchFamily="34" charset="-120"/>
               </a:rPr>
-              <a:t>✕  Đếm frame (sai)</a:t>
-            </a:r>
-            <a:endParaRPr lang="en-US" sz="1500" dirty="0"/>
-          </a:p>
-        </p:txBody>
-      </p:sp>
-      <p:sp>
-        <p:nvSpPr>
-          <p:cNvPr id="9" name="Text 7"/>
-          <p:cNvSpPr/>
-          <p:nvPr/>
-        </p:nvSpPr>
-        <p:spPr>
-          <a:xfrm>
-            <a:off x="777240" y="2331720"/>
-            <a:ext cx="4937760" cy="685800"/>
-          </a:xfrm>
-          <a:prstGeom prst="rect">
-            <a:avLst/>
-          </a:prstGeom>
-          <a:noFill/>
-          <a:ln/>
-        </p:spPr>
-        <p:txBody>
-          <a:bodyPr wrap="square" lIns="0" tIns="0" rIns="0" bIns="0" rtlCol="0" anchor="ctr"/>
-          <a:lstStyle/>
-          <a:p>
-            <a:pPr indent="0" marL="0">
-              <a:buNone/>
-            </a:pPr>
-            <a:r>
-              <a:rPr lang="en-US" sz="1250" dirty="0">
-                <a:solidFill>
-                  <a:srgbClr val="939BB0"/>
+              <a:t>Sinh mồi vàng: ghi deadline = now + 5000 ms</a:t>
+            </a:r>
+            <a:endParaRPr lang="en-US" sz="1450" dirty="0"/>
+          </a:p>
+          <a:p>
+            <a:pPr marL="342900" indent="-342900">
+              <a:spcAft>
+                <a:spcPts val="1200"/>
+              </a:spcAft>
+              <a:buSzPct val="100000"/>
+              <a:buChar char="•"/>
+            </a:pPr>
+            <a:r>
+              <a:rPr lang="en-US" sz="1450" dirty="0">
+                <a:solidFill>
+                  <a:srgbClr val="E9ECF4"/>
                 </a:solidFill>
                 <a:latin typeface="Calibri" pitchFamily="34" charset="0"/>
                 <a:ea typeface="Calibri" pitchFamily="34" charset="-122"/>
                 <a:cs typeface="Calibri" pitchFamily="34" charset="-120"/>
               </a:rPr>
-              <a:t>5 giây = 300 frame — chỉ đúng khi FPS không đổi. Máy lag hoặc tăng tốc độ là lệch ngay.</a:t>
-            </a:r>
-            <a:endParaRPr lang="en-US" sz="1250" dirty="0"/>
-          </a:p>
-        </p:txBody>
-      </p:sp>
-      <p:sp>
-        <p:nvSpPr>
-          <p:cNvPr id="10" name="Text 8"/>
-          <p:cNvSpPr/>
-          <p:nvPr/>
-        </p:nvSpPr>
-        <p:spPr>
-          <a:xfrm>
-            <a:off x="822960" y="3154680"/>
-            <a:ext cx="4754880" cy="1097280"/>
-          </a:xfrm>
-          <a:prstGeom prst="rect">
-            <a:avLst/>
-          </a:prstGeom>
-          <a:noFill/>
-          <a:ln/>
-        </p:spPr>
-        <p:txBody>
-          <a:bodyPr wrap="square" lIns="0" tIns="0" rIns="0" bIns="0" rtlCol="0" anchor="ctr"/>
+              <a:t>Mỗi bước rắn: so now ≥ deadline là xoá mồi</a:t>
+            </a:r>
+            <a:endParaRPr lang="en-US" sz="1450" dirty="0"/>
+          </a:p>
+          <a:p>
+            <a:pPr marL="342900" indent="-342900">
+              <a:spcAft>
+                <a:spcPts val="1200"/>
+              </a:spcAft>
+              <a:buSzPct val="100000"/>
+              <a:buChar char="•"/>
+            </a:pPr>
+            <a:r>
+              <a:rPr lang="en-US" sz="1450" dirty="0">
+                <a:solidFill>
+                  <a:srgbClr val="E9ECF4"/>
+                </a:solidFill>
+                <a:latin typeface="Calibri" pitchFamily="34" charset="0"/>
+                <a:ea typeface="Calibri" pitchFamily="34" charset="-122"/>
+                <a:cs typeface="Calibri" pitchFamily="34" charset="-120"/>
+              </a:rPr>
+              <a:t>FPS cao hay thấp, mồi vẫn sống đúng 5 giây</a:t>
+            </a:r>
+            <a:endParaRPr lang="en-US" sz="1450" dirty="0"/>
+          </a:p>
+          <a:p>
+            <a:pPr marL="342900" indent="-342900">
+              <a:spcAft>
+                <a:spcPts val="1200"/>
+              </a:spcAft>
+              <a:buSzPct val="100000"/>
+              <a:buChar char="•"/>
+            </a:pPr>
+            <a:r>
+              <a:rPr lang="en-US" sz="1450" dirty="0">
+                <a:solidFill>
+                  <a:srgbClr val="E9ECF4"/>
+                </a:solidFill>
+                <a:latin typeface="Calibri" pitchFamily="34" charset="0"/>
+                <a:ea typeface="Calibri" pitchFamily="34" charset="-122"/>
+                <a:cs typeface="Calibri" pitchFamily="34" charset="-120"/>
+              </a:rPr>
+              <a:t>HUD dùng lại mốc đó: remain = deadline − now</a:t>
+            </a:r>
+            <a:endParaRPr lang="en-US" sz="1450" dirty="0"/>
+          </a:p>
+        </p:txBody>
+      </p:sp>
+      <p:sp>
+        <p:nvSpPr>
+          <p:cNvPr id="8" name="Shape 6"/>
+          <p:cNvSpPr/>
+          <p:nvPr/>
+        </p:nvSpPr>
+        <p:spPr>
+          <a:xfrm>
+            <a:off x="6126480" y="1783080"/>
+            <a:ext cx="5486400" cy="2240280"/>
+          </a:xfrm>
+          <a:prstGeom prst="rect">
+            <a:avLst/>
+          </a:prstGeom>
+          <a:solidFill>
+            <a:srgbClr val="0F1119"/>
+          </a:solidFill>
+          <a:ln w="12700">
+            <a:solidFill>
+              <a:srgbClr val="2B3040"/>
+            </a:solidFill>
+            <a:prstDash val="solid"/>
+          </a:ln>
+        </p:spPr>
+      </p:sp>
+      <p:sp>
+        <p:nvSpPr>
+          <p:cNvPr id="9" name="Text 7"/>
+          <p:cNvSpPr/>
+          <p:nvPr/>
+        </p:nvSpPr>
+        <p:spPr>
+          <a:xfrm>
+            <a:off x="6355080" y="1947672"/>
+            <a:ext cx="5029200" cy="1911096"/>
+          </a:xfrm>
+          <a:prstGeom prst="rect">
+            <a:avLst/>
+          </a:prstGeom>
+          <a:noFill/>
+          <a:ln/>
+        </p:spPr>
+        <p:txBody>
+          <a:bodyPr wrap="square" lIns="0" tIns="0" rIns="0" bIns="0" rtlCol="0" anchor="t"/>
           <a:lstStyle/>
           <a:p>
             <a:pPr indent="0" marL="0">
               <a:lnSpc>
-                <a:spcPct val="120000"/>
+                <a:spcPct val="115000"/>
               </a:lnSpc>
               <a:buNone/>
             </a:pPr>
             <a:r>
-              <a:rPr lang="en-US" sz="1200" dirty="0">
-                <a:solidFill>
-                  <a:srgbClr val="E8B9BC"/>
+              <a:rPr lang="en-US" sz="1250" dirty="0">
+                <a:solidFill>
+                  <a:srgbClr val="D7DCE8"/>
                 </a:solidFill>
                 <a:latin typeface="Consolas" pitchFamily="34" charset="0"/>
                 <a:ea typeface="Consolas" pitchFamily="34" charset="-122"/>
                 <a:cs typeface="Consolas" pitchFamily="34" charset="-120"/>
               </a:rPr>
-              <a:t>if frames &gt; 300:</a:t>
-            </a:r>
-            <a:endParaRPr lang="en-US" sz="1200" dirty="0"/>
+              <a:t>now = pygame.time.get_ticks()</a:t>
+            </a:r>
+            <a:endParaRPr lang="en-US" sz="1250" dirty="0"/>
           </a:p>
           <a:p>
             <a:pPr indent="0" marL="0">
               <a:lnSpc>
-                <a:spcPct val="120000"/>
+                <a:spcPct val="115000"/>
               </a:lnSpc>
               <a:buNone/>
             </a:pPr>
             <a:r>
-              <a:rPr lang="en-US" sz="1200" dirty="0">
-                <a:solidFill>
-                  <a:srgbClr val="E8B9BC"/>
+              <a:rPr lang="en-US" sz="1250" dirty="0">
+                <a:solidFill>
+                  <a:srgbClr val="D7DCE8"/>
                 </a:solidFill>
                 <a:latin typeface="Consolas" pitchFamily="34" charset="0"/>
                 <a:ea typeface="Consolas" pitchFamily="34" charset="-122"/>
                 <a:cs typeface="Consolas" pitchFamily="34" charset="-120"/>
               </a:rPr>
-              <a:t>    remove_special()</a:t>
-            </a:r>
-            <a:endParaRPr lang="en-US" sz="1200" dirty="0"/>
-          </a:p>
-        </p:txBody>
-      </p:sp>
-      <p:sp>
-        <p:nvSpPr>
-          <p:cNvPr id="11" name="Shape 9"/>
-          <p:cNvSpPr/>
-          <p:nvPr/>
-        </p:nvSpPr>
-        <p:spPr>
-          <a:xfrm>
-            <a:off x="6172200" y="1828800"/>
-            <a:ext cx="5440680" cy="2651760"/>
-          </a:xfrm>
-          <a:prstGeom prst="rect">
-            <a:avLst/>
-          </a:prstGeom>
-          <a:solidFill>
-            <a:srgbClr val="16281C"/>
-          </a:solidFill>
-          <a:ln w="12700">
-            <a:solidFill>
-              <a:srgbClr val="2E6B45"/>
-            </a:solidFill>
-            <a:prstDash val="solid"/>
-          </a:ln>
-        </p:spPr>
-      </p:sp>
-      <p:sp>
-        <p:nvSpPr>
-          <p:cNvPr id="12" name="Text 10"/>
-          <p:cNvSpPr/>
-          <p:nvPr/>
-        </p:nvSpPr>
-        <p:spPr>
-          <a:xfrm>
-            <a:off x="6400800" y="1938528"/>
-            <a:ext cx="4937760" cy="365760"/>
-          </a:xfrm>
-          <a:prstGeom prst="rect">
-            <a:avLst/>
-          </a:prstGeom>
-          <a:noFill/>
-          <a:ln/>
-        </p:spPr>
-        <p:txBody>
-          <a:bodyPr wrap="square" lIns="0" tIns="0" rIns="0" bIns="0" rtlCol="0" anchor="ctr"/>
-          <a:lstStyle/>
-          <a:p>
-            <a:pPr indent="0" marL="0">
-              <a:buNone/>
-            </a:pPr>
-            <a:r>
-              <a:rPr lang="en-US" sz="1500" b="1" dirty="0">
-                <a:solidFill>
-                  <a:srgbClr val="6EE787"/>
-                </a:solidFill>
-                <a:latin typeface="Calibri" pitchFamily="34" charset="0"/>
-                <a:ea typeface="Calibri" pitchFamily="34" charset="-122"/>
-                <a:cs typeface="Calibri" pitchFamily="34" charset="-120"/>
-              </a:rPr>
-              <a:t>✓  Mốc thời gian tuyệt đối (đúng)</a:t>
-            </a:r>
-            <a:endParaRPr lang="en-US" sz="1500" dirty="0"/>
-          </a:p>
-        </p:txBody>
-      </p:sp>
-      <p:sp>
-        <p:nvSpPr>
-          <p:cNvPr id="13" name="Text 11"/>
-          <p:cNvSpPr/>
-          <p:nvPr/>
-        </p:nvSpPr>
-        <p:spPr>
-          <a:xfrm>
-            <a:off x="6400800" y="2331720"/>
-            <a:ext cx="4937760" cy="685800"/>
-          </a:xfrm>
-          <a:prstGeom prst="rect">
-            <a:avLst/>
-          </a:prstGeom>
-          <a:noFill/>
-          <a:ln/>
-        </p:spPr>
-        <p:txBody>
-          <a:bodyPr wrap="square" lIns="0" tIns="0" rIns="0" bIns="0" rtlCol="0" anchor="ctr"/>
-          <a:lstStyle/>
-          <a:p>
-            <a:pPr indent="0" marL="0">
-              <a:buNone/>
-            </a:pPr>
-            <a:r>
-              <a:rPr lang="en-US" sz="1250" dirty="0">
-                <a:solidFill>
-                  <a:srgbClr val="939BB0"/>
-                </a:solidFill>
-                <a:latin typeface="Calibri" pitchFamily="34" charset="0"/>
-                <a:ea typeface="Calibri" pitchFamily="34" charset="-122"/>
-                <a:cs typeface="Calibri" pitchFamily="34" charset="-120"/>
-              </a:rPr>
-              <a:t>Sinh mồi: ghi deadline = now + 5000. Mỗi bước chỉ so now ≥ deadline — FPS nào cũng đúng 5 giây.</a:t>
+              <a:t>deadline = now + 5000</a:t>
             </a:r>
             <a:endParaRPr lang="en-US" sz="1250" dirty="0"/>
           </a:p>
-        </p:txBody>
-      </p:sp>
-      <p:sp>
-        <p:nvSpPr>
-          <p:cNvPr id="14" name="Text 12"/>
-          <p:cNvSpPr/>
-          <p:nvPr/>
-        </p:nvSpPr>
-        <p:spPr>
-          <a:xfrm>
-            <a:off x="6446520" y="3154680"/>
-            <a:ext cx="4846320" cy="1234440"/>
-          </a:xfrm>
-          <a:prstGeom prst="rect">
-            <a:avLst/>
-          </a:prstGeom>
-          <a:noFill/>
-          <a:ln/>
-        </p:spPr>
-        <p:txBody>
-          <a:bodyPr wrap="square" lIns="0" tIns="0" rIns="0" bIns="0" rtlCol="0" anchor="ctr"/>
-          <a:lstStyle/>
           <a:p>
             <a:pPr indent="0" marL="0">
               <a:lnSpc>
-                <a:spcPct val="120000"/>
+                <a:spcPct val="115000"/>
               </a:lnSpc>
               <a:buNone/>
             </a:pPr>
-            <a:r>
-              <a:rPr lang="en-US" sz="1200" dirty="0">
-                <a:solidFill>
-                  <a:srgbClr val="B9E8C4"/>
+            <a:endParaRPr lang="en-US" sz="1250" dirty="0"/>
+          </a:p>
+          <a:p>
+            <a:pPr indent="0" marL="0">
+              <a:lnSpc>
+                <a:spcPct val="115000"/>
+              </a:lnSpc>
+              <a:buNone/>
+            </a:pPr>
+            <a:r>
+              <a:rPr lang="en-US" sz="1250" dirty="0">
+                <a:solidFill>
+                  <a:srgbClr val="D7DCE8"/>
                 </a:solidFill>
                 <a:latin typeface="Consolas" pitchFamily="34" charset="0"/>
                 <a:ea typeface="Consolas" pitchFamily="34" charset="-122"/>
                 <a:cs typeface="Consolas" pitchFamily="34" charset="-120"/>
               </a:rPr>
-              <a:t>deadline = now + 5000</a:t>
-            </a:r>
-            <a:endParaRPr lang="en-US" sz="1200" dirty="0"/>
+              <a:t># mỗi bước rắn</a:t>
+            </a:r>
+            <a:endParaRPr lang="en-US" sz="1250" dirty="0"/>
           </a:p>
           <a:p>
             <a:pPr indent="0" marL="0">
               <a:lnSpc>
-                <a:spcPct val="120000"/>
+                <a:spcPct val="115000"/>
               </a:lnSpc>
               <a:buNone/>
             </a:pPr>
             <a:r>
-              <a:rPr lang="en-US" sz="1200" dirty="0">
-                <a:solidFill>
-                  <a:srgbClr val="B9E8C4"/>
+              <a:rPr lang="en-US" sz="1250" dirty="0">
+                <a:solidFill>
+                  <a:srgbClr val="D7DCE8"/>
                 </a:solidFill>
                 <a:latin typeface="Consolas" pitchFamily="34" charset="0"/>
                 <a:ea typeface="Consolas" pitchFamily="34" charset="-122"/>
@@ -6997,19 +6909,19 @@
               </a:rPr>
               <a:t>if now &gt;= deadline:</a:t>
             </a:r>
-            <a:endParaRPr lang="en-US" sz="1200" dirty="0"/>
+            <a:endParaRPr lang="en-US" sz="1250" dirty="0"/>
           </a:p>
           <a:p>
             <a:pPr indent="0" marL="0">
               <a:lnSpc>
-                <a:spcPct val="120000"/>
+                <a:spcPct val="115000"/>
               </a:lnSpc>
               <a:buNone/>
             </a:pPr>
             <a:r>
-              <a:rPr lang="en-US" sz="1200" dirty="0">
-                <a:solidFill>
-                  <a:srgbClr val="B9E8C4"/>
+              <a:rPr lang="en-US" sz="1250" dirty="0">
+                <a:solidFill>
+                  <a:srgbClr val="D7DCE8"/>
                 </a:solidFill>
                 <a:latin typeface="Consolas" pitchFamily="34" charset="0"/>
                 <a:ea typeface="Consolas" pitchFamily="34" charset="-122"/>
@@ -7017,13 +6929,13 @@
               </a:rPr>
               <a:t>    remove_special()</a:t>
             </a:r>
-            <a:endParaRPr lang="en-US" sz="1200" dirty="0"/>
-          </a:p>
-        </p:txBody>
-      </p:sp>
-      <p:sp>
-        <p:nvSpPr>
-          <p:cNvPr id="15" name="Shape 13"/>
+            <a:endParaRPr lang="en-US" sz="1250" dirty="0"/>
+          </a:p>
+        </p:txBody>
+      </p:sp>
+      <p:sp>
+        <p:nvSpPr>
+          <p:cNvPr id="10" name="Shape 8"/>
           <p:cNvSpPr/>
           <p:nvPr/>
         </p:nvSpPr>
@@ -7048,7 +6960,7 @@
       </p:sp>
       <p:sp>
         <p:nvSpPr>
-          <p:cNvPr id="16" name="Text 14"/>
+          <p:cNvPr id="11" name="Text 9"/>
           <p:cNvSpPr/>
           <p:nvPr/>
         </p:nvSpPr>

</xml_diff>

<commit_message>
fix: nut choi lai bam duoc, R moi luc, dieu khien WASD
</commit_message>
<xml_diff>
--- a/docs/Bai-4-Ran-san-moi-Ly-thuyet-va-ky-thuat.pptx
+++ b/docs/Bai-4-Ran-san-moi-Ly-thuyet-va-ky-thuat.pptx
@@ -4043,7 +4043,7 @@
                 <a:ea typeface="Calibri" pitchFamily="34" charset="-122"/>
                 <a:cs typeface="Calibri" pitchFamily="34" charset="-120"/>
               </a:rPr>
-              <a:t>▲</a:t>
+              <a:t>W</a:t>
             </a:r>
             <a:endParaRPr lang="en-US" sz="2000" dirty="0"/>
           </a:p>
@@ -4107,7 +4107,7 @@
                 <a:ea typeface="Calibri" pitchFamily="34" charset="-122"/>
                 <a:cs typeface="Calibri" pitchFamily="34" charset="-120"/>
               </a:rPr>
-              <a:t>◀</a:t>
+              <a:t>A</a:t>
             </a:r>
             <a:endParaRPr lang="en-US" sz="2000" dirty="0"/>
           </a:p>
@@ -4171,7 +4171,7 @@
                 <a:ea typeface="Calibri" pitchFamily="34" charset="-122"/>
                 <a:cs typeface="Calibri" pitchFamily="34" charset="-120"/>
               </a:rPr>
-              <a:t>▼</a:t>
+              <a:t>S</a:t>
             </a:r>
             <a:endParaRPr lang="en-US" sz="2000" dirty="0"/>
           </a:p>
@@ -4235,7 +4235,7 @@
                 <a:ea typeface="Calibri" pitchFamily="34" charset="-122"/>
                 <a:cs typeface="Calibri" pitchFamily="34" charset="-120"/>
               </a:rPr>
-              <a:t>▶</a:t>
+              <a:t>D</a:t>
             </a:r>
             <a:endParaRPr lang="en-US" sz="2000" dirty="0"/>
           </a:p>
@@ -4274,7 +4274,7 @@
                 <a:ea typeface="Calibri" pitchFamily="34" charset="-122"/>
                 <a:cs typeface="Calibri" pitchFamily="34" charset="-120"/>
               </a:rPr>
-              <a:t>mũi tên hoặc WASD</a:t>
+              <a:t>WASD — bốn hướng cố định</a:t>
             </a:r>
             <a:endParaRPr lang="en-US" sz="1250" dirty="0"/>
           </a:p>
@@ -4586,7 +4586,7 @@
                 <a:ea typeface="Calibri" pitchFamily="34" charset="-122"/>
                 <a:cs typeface="Calibri" pitchFamily="34" charset="-120"/>
               </a:rPr>
-              <a:t>P tạm dừng · R chơi lại · Esc thoát</a:t>
+              <a:t>P tạm dừng · R hoặc nút chơi lại · Esc thoát</a:t>
             </a:r>
             <a:endParaRPr lang="en-US" sz="1450" dirty="0"/>
           </a:p>
@@ -9101,7 +9101,7 @@
                 <a:ea typeface="Calibri" pitchFamily="34" charset="-122"/>
                 <a:cs typeface="Calibri" pitchFamily="34" charset="-120"/>
               </a:rPr>
-              <a:t>Game over — R chơi lại, Esc thoát</a:t>
+              <a:t>Game over — R hoặc nút chơi lại, Esc thoát</a:t>
             </a:r>
             <a:endParaRPr lang="en-US" sz="1350" dirty="0"/>
           </a:p>

</xml_diff>